<commit_message>
Work session updates - March 20, 2026
- Store Updates Dashboard port management and testing (port 8081)
- Zorro Audio pipeline enhancements and diagnostics
- TDA Insights weekly report generation and automation
- JobCodes-teaming dashboard backend debugging
- Service startup and process management improvements
- Flask application testing and configuration updates
- Audio synthesis and SSML validation scripts
</commit_message>
<xml_diff>
--- a/Store Support/Projects/TDA Insights/TDA_WK7_Report.pptx
+++ b/Store Support/Projects/TDA Insights/TDA_WK7_Report.pptx
@@ -20,6 +20,7 @@
     <p:sldId id="271" r:id="rId16"/>
     <p:sldId id="272" r:id="rId17"/>
     <p:sldId id="273" r:id="rId18"/>
+    <p:sldId id="274" r:id="rId19"/>
   </p:sldIdLst>
   <p:sldSz cx="9144000" cy="6858000" type="custom"/>
   <p:notesSz cx="6858000" cy="9144000"/>
@@ -368,7 +369,7 @@
         <p:spPr>
           <a:xfrm>
             <a:off x="0" y="0"/>
-            <a:ext cx="9144000" cy="4814675"/>
+            <a:ext cx="9144000" cy="6858000"/>
           </a:xfrm>
           <a:prstGeom prst="rect">
             <a:avLst/>
@@ -472,7 +473,7 @@
         <p:spPr>
           <a:xfrm>
             <a:off x="0" y="0"/>
-            <a:ext cx="9144000" cy="3285821"/>
+            <a:ext cx="9144000" cy="6858000"/>
           </a:xfrm>
           <a:prstGeom prst="rect">
             <a:avLst/>
@@ -524,7 +525,7 @@
         <p:spPr>
           <a:xfrm>
             <a:off x="0" y="0"/>
-            <a:ext cx="9144000" cy="1960815"/>
+            <a:ext cx="9144000" cy="6858000"/>
           </a:xfrm>
           <a:prstGeom prst="rect">
             <a:avLst/>
@@ -576,6 +577,110 @@
         <p:spPr>
           <a:xfrm>
             <a:off x="0" y="0"/>
+            <a:ext cx="9144000" cy="1407515"/>
+          </a:xfrm>
+          <a:prstGeom prst="rect">
+            <a:avLst/>
+          </a:prstGeom>
+        </p:spPr>
+      </p:pic>
+    </p:spTree>
+  </p:cSld>
+</p:sld>
+</file>
+
+<file path=ppt/slides/slide18.xml><?xml version="1.0" encoding="utf-8"?>
+<p:sld xmlns:p="http://schemas.openxmlformats.org/presentationml/2006/main" xmlns:a="http://schemas.openxmlformats.org/drawingml/2006/main" xmlns:r="http://schemas.openxmlformats.org/officeDocument/2006/relationships">
+  <p:cSld>
+    <p:bg>
+      <p:bgPr>
+        <a:solidFill>
+          <a:srgbClr val="FFFFFF"/>
+        </a:solidFill>
+        <a:effectLst/>
+      </p:bgPr>
+    </p:bg>
+    <p:spTree>
+      <p:nvGrpSpPr>
+        <p:cNvPr id="1" name=""/>
+        <p:cNvGrpSpPr/>
+        <p:nvPr/>
+      </p:nvGrpSpPr>
+      <p:grpSpPr>
+        <a:xfrm>
+          <a:off x="0" y="0"/>
+          <a:ext cx="9144000" cy="6858000"/>
+        </a:xfrm>
+      </p:grpSpPr>
+      <p:pic>
+        <p:nvPicPr>
+          <p:cNvPr id="2" name="Screenshot"/>
+          <p:cNvPicPr>
+            <a:picLocks noChangeAspect="1"/>
+          </p:cNvPicPr>
+          <p:nvPr/>
+        </p:nvPicPr>
+        <p:blipFill>
+          <a:blip r:embed="rId1"/>
+          <a:stretch>
+            <a:fillRect/>
+          </a:stretch>
+        </p:blipFill>
+        <p:spPr>
+          <a:xfrm>
+            <a:off x="0" y="0"/>
+            <a:ext cx="9144000" cy="6770636"/>
+          </a:xfrm>
+          <a:prstGeom prst="rect">
+            <a:avLst/>
+          </a:prstGeom>
+        </p:spPr>
+      </p:pic>
+    </p:spTree>
+  </p:cSld>
+</p:sld>
+</file>
+
+<file path=ppt/slides/slide19.xml><?xml version="1.0" encoding="utf-8"?>
+<p:sld xmlns:p="http://schemas.openxmlformats.org/presentationml/2006/main" xmlns:a="http://schemas.openxmlformats.org/drawingml/2006/main" xmlns:r="http://schemas.openxmlformats.org/officeDocument/2006/relationships">
+  <p:cSld>
+    <p:bg>
+      <p:bgPr>
+        <a:solidFill>
+          <a:srgbClr val="FFFFFF"/>
+        </a:solidFill>
+        <a:effectLst/>
+      </p:bgPr>
+    </p:bg>
+    <p:spTree>
+      <p:nvGrpSpPr>
+        <p:cNvPr id="1" name=""/>
+        <p:cNvGrpSpPr/>
+        <p:nvPr/>
+      </p:nvGrpSpPr>
+      <p:grpSpPr>
+        <a:xfrm>
+          <a:off x="0" y="0"/>
+          <a:ext cx="9144000" cy="6858000"/>
+        </a:xfrm>
+      </p:grpSpPr>
+      <p:pic>
+        <p:nvPicPr>
+          <p:cNvPr id="2" name="Screenshot"/>
+          <p:cNvPicPr>
+            <a:picLocks noChangeAspect="1"/>
+          </p:cNvPicPr>
+          <p:nvPr/>
+        </p:nvPicPr>
+        <p:blipFill>
+          <a:blip r:embed="rId1"/>
+          <a:stretch>
+            <a:fillRect/>
+          </a:stretch>
+        </p:blipFill>
+        <p:spPr>
+          <a:xfrm>
+            <a:off x="0" y="0"/>
             <a:ext cx="9144000" cy="6858000"/>
           </a:xfrm>
           <a:prstGeom prst="rect">
@@ -588,58 +693,6 @@
 </p:sld>
 </file>
 
-<file path=ppt/slides/slide18.xml><?xml version="1.0" encoding="utf-8"?>
-<p:sld xmlns:p="http://schemas.openxmlformats.org/presentationml/2006/main" xmlns:a="http://schemas.openxmlformats.org/drawingml/2006/main" xmlns:r="http://schemas.openxmlformats.org/officeDocument/2006/relationships">
-  <p:cSld>
-    <p:bg>
-      <p:bgPr>
-        <a:solidFill>
-          <a:srgbClr val="FFFFFF"/>
-        </a:solidFill>
-        <a:effectLst/>
-      </p:bgPr>
-    </p:bg>
-    <p:spTree>
-      <p:nvGrpSpPr>
-        <p:cNvPr id="1" name=""/>
-        <p:cNvGrpSpPr/>
-        <p:nvPr/>
-      </p:nvGrpSpPr>
-      <p:grpSpPr>
-        <a:xfrm>
-          <a:off x="0" y="0"/>
-          <a:ext cx="9144000" cy="6858000"/>
-        </a:xfrm>
-      </p:grpSpPr>
-      <p:pic>
-        <p:nvPicPr>
-          <p:cNvPr id="2" name="Screenshot"/>
-          <p:cNvPicPr>
-            <a:picLocks noChangeAspect="1"/>
-          </p:cNvPicPr>
-          <p:nvPr/>
-        </p:nvPicPr>
-        <p:blipFill>
-          <a:blip r:embed="rId1"/>
-          <a:stretch>
-            <a:fillRect/>
-          </a:stretch>
-        </p:blipFill>
-        <p:spPr>
-          <a:xfrm>
-            <a:off x="0" y="0"/>
-            <a:ext cx="9144000" cy="5358267"/>
-          </a:xfrm>
-          <a:prstGeom prst="rect">
-            <a:avLst/>
-          </a:prstGeom>
-        </p:spPr>
-      </p:pic>
-    </p:spTree>
-  </p:cSld>
-</p:sld>
-</file>
-
 <file path=ppt/slides/slide2.xml><?xml version="1.0" encoding="utf-8"?>
 <p:sld xmlns:p="http://schemas.openxmlformats.org/presentationml/2006/main" xmlns:a="http://schemas.openxmlformats.org/drawingml/2006/main" xmlns:r="http://schemas.openxmlformats.org/officeDocument/2006/relationships">
   <p:cSld>
@@ -732,7 +785,7 @@
         <p:spPr>
           <a:xfrm>
             <a:off x="0" y="0"/>
-            <a:ext cx="9144000" cy="1689019"/>
+            <a:ext cx="9144000" cy="1407515"/>
           </a:xfrm>
           <a:prstGeom prst="rect">
             <a:avLst/>
@@ -784,7 +837,7 @@
         <p:spPr>
           <a:xfrm>
             <a:off x="0" y="0"/>
-            <a:ext cx="9144000" cy="5256343"/>
+            <a:ext cx="9144000" cy="6858000"/>
           </a:xfrm>
           <a:prstGeom prst="rect">
             <a:avLst/>
@@ -888,6 +941,162 @@
         <p:spPr>
           <a:xfrm>
             <a:off x="0" y="0"/>
+            <a:ext cx="9144000" cy="2319974"/>
+          </a:xfrm>
+          <a:prstGeom prst="rect">
+            <a:avLst/>
+          </a:prstGeom>
+        </p:spPr>
+      </p:pic>
+    </p:spTree>
+  </p:cSld>
+</p:sld>
+</file>
+
+<file path=ppt/slides/slide7.xml><?xml version="1.0" encoding="utf-8"?>
+<p:sld xmlns:p="http://schemas.openxmlformats.org/presentationml/2006/main" xmlns:a="http://schemas.openxmlformats.org/drawingml/2006/main" xmlns:r="http://schemas.openxmlformats.org/officeDocument/2006/relationships">
+  <p:cSld>
+    <p:bg>
+      <p:bgPr>
+        <a:solidFill>
+          <a:srgbClr val="FFFFFF"/>
+        </a:solidFill>
+        <a:effectLst/>
+      </p:bgPr>
+    </p:bg>
+    <p:spTree>
+      <p:nvGrpSpPr>
+        <p:cNvPr id="1" name=""/>
+        <p:cNvGrpSpPr/>
+        <p:nvPr/>
+      </p:nvGrpSpPr>
+      <p:grpSpPr>
+        <a:xfrm>
+          <a:off x="0" y="0"/>
+          <a:ext cx="9144000" cy="6858000"/>
+        </a:xfrm>
+      </p:grpSpPr>
+      <p:pic>
+        <p:nvPicPr>
+          <p:cNvPr id="2" name="Screenshot"/>
+          <p:cNvPicPr>
+            <a:picLocks noChangeAspect="1"/>
+          </p:cNvPicPr>
+          <p:nvPr/>
+        </p:nvPicPr>
+        <p:blipFill>
+          <a:blip r:embed="rId1"/>
+          <a:stretch>
+            <a:fillRect/>
+          </a:stretch>
+        </p:blipFill>
+        <p:spPr>
+          <a:xfrm>
+            <a:off x="0" y="0"/>
+            <a:ext cx="9144000" cy="3746904"/>
+          </a:xfrm>
+          <a:prstGeom prst="rect">
+            <a:avLst/>
+          </a:prstGeom>
+        </p:spPr>
+      </p:pic>
+    </p:spTree>
+  </p:cSld>
+</p:sld>
+</file>
+
+<file path=ppt/slides/slide8.xml><?xml version="1.0" encoding="utf-8"?>
+<p:sld xmlns:p="http://schemas.openxmlformats.org/presentationml/2006/main" xmlns:a="http://schemas.openxmlformats.org/drawingml/2006/main" xmlns:r="http://schemas.openxmlformats.org/officeDocument/2006/relationships">
+  <p:cSld>
+    <p:bg>
+      <p:bgPr>
+        <a:solidFill>
+          <a:srgbClr val="FFFFFF"/>
+        </a:solidFill>
+        <a:effectLst/>
+      </p:bgPr>
+    </p:bg>
+    <p:spTree>
+      <p:nvGrpSpPr>
+        <p:cNvPr id="1" name=""/>
+        <p:cNvGrpSpPr/>
+        <p:nvPr/>
+      </p:nvGrpSpPr>
+      <p:grpSpPr>
+        <a:xfrm>
+          <a:off x="0" y="0"/>
+          <a:ext cx="9144000" cy="6858000"/>
+        </a:xfrm>
+      </p:grpSpPr>
+      <p:pic>
+        <p:nvPicPr>
+          <p:cNvPr id="2" name="Screenshot"/>
+          <p:cNvPicPr>
+            <a:picLocks noChangeAspect="1"/>
+          </p:cNvPicPr>
+          <p:nvPr/>
+        </p:nvPicPr>
+        <p:blipFill>
+          <a:blip r:embed="rId1"/>
+          <a:stretch>
+            <a:fillRect/>
+          </a:stretch>
+        </p:blipFill>
+        <p:spPr>
+          <a:xfrm>
+            <a:off x="0" y="0"/>
+            <a:ext cx="9144000" cy="2184076"/>
+          </a:xfrm>
+          <a:prstGeom prst="rect">
+            <a:avLst/>
+          </a:prstGeom>
+        </p:spPr>
+      </p:pic>
+    </p:spTree>
+  </p:cSld>
+</p:sld>
+</file>
+
+<file path=ppt/slides/slide9.xml><?xml version="1.0" encoding="utf-8"?>
+<p:sld xmlns:p="http://schemas.openxmlformats.org/presentationml/2006/main" xmlns:a="http://schemas.openxmlformats.org/drawingml/2006/main" xmlns:r="http://schemas.openxmlformats.org/officeDocument/2006/relationships">
+  <p:cSld>
+    <p:bg>
+      <p:bgPr>
+        <a:solidFill>
+          <a:srgbClr val="FFFFFF"/>
+        </a:solidFill>
+        <a:effectLst/>
+      </p:bgPr>
+    </p:bg>
+    <p:spTree>
+      <p:nvGrpSpPr>
+        <p:cNvPr id="1" name=""/>
+        <p:cNvGrpSpPr/>
+        <p:nvPr/>
+      </p:nvGrpSpPr>
+      <p:grpSpPr>
+        <a:xfrm>
+          <a:off x="0" y="0"/>
+          <a:ext cx="9144000" cy="6858000"/>
+        </a:xfrm>
+      </p:grpSpPr>
+      <p:pic>
+        <p:nvPicPr>
+          <p:cNvPr id="2" name="Screenshot"/>
+          <p:cNvPicPr>
+            <a:picLocks noChangeAspect="1"/>
+          </p:cNvPicPr>
+          <p:nvPr/>
+        </p:nvPicPr>
+        <p:blipFill>
+          <a:blip r:embed="rId1"/>
+          <a:stretch>
+            <a:fillRect/>
+          </a:stretch>
+        </p:blipFill>
+        <p:spPr>
+          <a:xfrm>
+            <a:off x="0" y="0"/>
             <a:ext cx="9144000" cy="6858000"/>
           </a:xfrm>
           <a:prstGeom prst="rect">
@@ -898,160 +1107,4 @@
     </p:spTree>
   </p:cSld>
 </p:sld>
-</file>
-
-<file path=ppt/slides/slide7.xml><?xml version="1.0" encoding="utf-8"?>
-<p:sld xmlns:p="http://schemas.openxmlformats.org/presentationml/2006/main" xmlns:a="http://schemas.openxmlformats.org/drawingml/2006/main" xmlns:r="http://schemas.openxmlformats.org/officeDocument/2006/relationships">
-  <p:cSld>
-    <p:bg>
-      <p:bgPr>
-        <a:solidFill>
-          <a:srgbClr val="FFFFFF"/>
-        </a:solidFill>
-        <a:effectLst/>
-      </p:bgPr>
-    </p:bg>
-    <p:spTree>
-      <p:nvGrpSpPr>
-        <p:cNvPr id="1" name=""/>
-        <p:cNvGrpSpPr/>
-        <p:nvPr/>
-      </p:nvGrpSpPr>
-      <p:grpSpPr>
-        <a:xfrm>
-          <a:off x="0" y="0"/>
-          <a:ext cx="9144000" cy="6858000"/>
-        </a:xfrm>
-      </p:grpSpPr>
-      <p:pic>
-        <p:nvPicPr>
-          <p:cNvPr id="2" name="Screenshot"/>
-          <p:cNvPicPr>
-            <a:picLocks noChangeAspect="1"/>
-          </p:cNvPicPr>
-          <p:nvPr/>
-        </p:nvPicPr>
-        <p:blipFill>
-          <a:blip r:embed="rId1"/>
-          <a:stretch>
-            <a:fillRect/>
-          </a:stretch>
-        </p:blipFill>
-        <p:spPr>
-          <a:xfrm>
-            <a:off x="0" y="0"/>
-            <a:ext cx="9144000" cy="5086471"/>
-          </a:xfrm>
-          <a:prstGeom prst="rect">
-            <a:avLst/>
-          </a:prstGeom>
-        </p:spPr>
-      </p:pic>
-    </p:spTree>
-  </p:cSld>
-</p:sld>
-</file>
-
-<file path=ppt/slides/slide8.xml><?xml version="1.0" encoding="utf-8"?>
-<p:sld xmlns:p="http://schemas.openxmlformats.org/presentationml/2006/main" xmlns:a="http://schemas.openxmlformats.org/drawingml/2006/main" xmlns:r="http://schemas.openxmlformats.org/officeDocument/2006/relationships">
-  <p:cSld>
-    <p:bg>
-      <p:bgPr>
-        <a:solidFill>
-          <a:srgbClr val="FFFFFF"/>
-        </a:solidFill>
-        <a:effectLst/>
-      </p:bgPr>
-    </p:bg>
-    <p:spTree>
-      <p:nvGrpSpPr>
-        <p:cNvPr id="1" name=""/>
-        <p:cNvGrpSpPr/>
-        <p:nvPr/>
-      </p:nvGrpSpPr>
-      <p:grpSpPr>
-        <a:xfrm>
-          <a:off x="0" y="0"/>
-          <a:ext cx="9144000" cy="6858000"/>
-        </a:xfrm>
-      </p:grpSpPr>
-      <p:pic>
-        <p:nvPicPr>
-          <p:cNvPr id="2" name="Screenshot"/>
-          <p:cNvPicPr>
-            <a:picLocks noChangeAspect="1"/>
-          </p:cNvPicPr>
-          <p:nvPr/>
-        </p:nvPicPr>
-        <p:blipFill>
-          <a:blip r:embed="rId1"/>
-          <a:stretch>
-            <a:fillRect/>
-          </a:stretch>
-        </p:blipFill>
-        <p:spPr>
-          <a:xfrm>
-            <a:off x="0" y="0"/>
-            <a:ext cx="9144000" cy="6858000"/>
-          </a:xfrm>
-          <a:prstGeom prst="rect">
-            <a:avLst/>
-          </a:prstGeom>
-        </p:spPr>
-      </p:pic>
-    </p:spTree>
-  </p:cSld>
-</p:sld>
-</file>
-
-<file path=ppt/slides/slide9.xml><?xml version="1.0" encoding="utf-8"?>
-<p:sld xmlns:p="http://schemas.openxmlformats.org/presentationml/2006/main" xmlns:a="http://schemas.openxmlformats.org/drawingml/2006/main" xmlns:r="http://schemas.openxmlformats.org/officeDocument/2006/relationships">
-  <p:cSld>
-    <p:bg>
-      <p:bgPr>
-        <a:solidFill>
-          <a:srgbClr val="FFFFFF"/>
-        </a:solidFill>
-        <a:effectLst/>
-      </p:bgPr>
-    </p:bg>
-    <p:spTree>
-      <p:nvGrpSpPr>
-        <p:cNvPr id="1" name=""/>
-        <p:cNvGrpSpPr/>
-        <p:nvPr/>
-      </p:nvGrpSpPr>
-      <p:grpSpPr>
-        <a:xfrm>
-          <a:off x="0" y="0"/>
-          <a:ext cx="9144000" cy="6858000"/>
-        </a:xfrm>
-      </p:grpSpPr>
-      <p:pic>
-        <p:nvPicPr>
-          <p:cNvPr id="2" name="Screenshot"/>
-          <p:cNvPicPr>
-            <a:picLocks noChangeAspect="1"/>
-          </p:cNvPicPr>
-          <p:nvPr/>
-        </p:nvPicPr>
-        <p:blipFill>
-          <a:blip r:embed="rId1"/>
-          <a:stretch>
-            <a:fillRect/>
-          </a:stretch>
-        </p:blipFill>
-        <p:spPr>
-          <a:xfrm>
-            <a:off x="0" y="0"/>
-            <a:ext cx="9144000" cy="6858000"/>
-          </a:xfrm>
-          <a:prstGeom prst="rect">
-            <a:avLst/>
-          </a:prstGeom>
-        </p:spPr>
-      </p:pic>
-    </p:spTree>
-  </p:cSld>
-</p:sld>
 </file>
</xml_diff>